<commit_message>
vault backup: 2026-05-11 21:29:08
</commit_message>
<xml_diff>
--- a/MyBrain/notes/ucsd/Spring 2026/ECE284/MedHALT_Slides_9_to_15.pptx
+++ b/MyBrain/notes/ucsd/Spring 2026/ECE284/MedHALT_Slides_9_to_15.pptx
@@ -3806,13 +3806,13 @@
           <a:p>
             <a:pPr algn="ctr"/>
             <a:r>
-              <a:rPr sz="6000" b="1" i="0">
+              <a:rPr sz="5400" b="1" i="0">
                 <a:solidFill>
                   <a:srgbClr val="2D8A4E"/>
                 </a:solidFill>
                 <a:latin typeface="Helvetica"/>
               </a:rPr>
-              <a:t>RHT  72%  ⭐</a:t>
+              <a:t>RHT  72.33%  ⭐</a:t>
             </a:r>
           </a:p>
           <a:p>
@@ -3878,13 +3878,13 @@
           <a:p>
             <a:pPr algn="ctr"/>
             <a:r>
-              <a:rPr sz="6000" b="1" i="0">
+              <a:rPr sz="5400" b="1" i="0">
                 <a:solidFill>
                   <a:srgbClr val="CC4C54"/>
                 </a:solidFill>
                 <a:latin typeface="Helvetica"/>
               </a:rPr>
-              <a:t>RHT  11%  ❌</a:t>
+              <a:t>RHT  11.26%  ❌</a:t>
             </a:r>
           </a:p>
           <a:p>
@@ -4028,6 +4028,66 @@
                 <a:latin typeface="Helvetica"/>
               </a:rPr>
               <a:t>  = Base + SFT + RLHF</a:t>
+            </a:r>
+          </a:p>
+          <a:p>
+            <a:pPr algn="l"/>
+            <a:r>
+              <a:rPr sz="1700" b="0" i="1">
+                <a:solidFill>
+                  <a:srgbClr val="666666"/>
+                </a:solidFill>
+                <a:latin typeface="Helvetica"/>
+              </a:rPr>
+              <a:t>    • SFT = Supervised Fine-Tuning</a:t>
+            </a:r>
+          </a:p>
+          <a:p>
+            <a:pPr algn="l"/>
+            <a:r>
+              <a:rPr sz="1600" b="0" i="1">
+                <a:solidFill>
+                  <a:srgbClr val="666666"/>
+                </a:solidFill>
+                <a:latin typeface="Helvetica"/>
+              </a:rPr>
+              <a:t>       (teaches conversation format)</a:t>
+            </a:r>
+          </a:p>
+          <a:p>
+            <a:pPr algn="l"/>
+            <a:r>
+              <a:rPr sz="1700" b="0" i="1">
+                <a:solidFill>
+                  <a:srgbClr val="666666"/>
+                </a:solidFill>
+                <a:latin typeface="Helvetica"/>
+              </a:rPr>
+              <a:t>    • RLHF = Reinforcement Learning</a:t>
+            </a:r>
+          </a:p>
+          <a:p>
+            <a:pPr algn="l"/>
+            <a:r>
+              <a:rPr sz="1700" b="0" i="1">
+                <a:solidFill>
+                  <a:srgbClr val="666666"/>
+                </a:solidFill>
+                <a:latin typeface="Helvetica"/>
+              </a:rPr>
+              <a:t>       from Human Feedback</a:t>
+            </a:r>
+          </a:p>
+          <a:p>
+            <a:pPr algn="l"/>
+            <a:r>
+              <a:rPr sz="1600" b="0" i="1">
+                <a:solidFill>
+                  <a:srgbClr val="666666"/>
+                </a:solidFill>
+                <a:latin typeface="Helvetica"/>
+              </a:rPr>
+              <a:t>       (tunes for human preference)</a:t>
             </a:r>
           </a:p>
           <a:p>
@@ -4365,7 +4425,7 @@
                           </a:solidFill>
                           <a:latin typeface="Helvetica"/>
                         </a:rPr>
-                        <a:t>72%  ⭐</a:t>
+                        <a:t>72.33%  ⭐</a:t>
                       </a:r>
                     </a:p>
                     <a:p>
@@ -4396,7 +4456,7 @@
                           </a:solidFill>
                           <a:latin typeface="Helvetica"/>
                         </a:rPr>
-                        <a:t>8%</a:t>
+                        <a:t>8.04%</a:t>
                       </a:r>
                     </a:p>
                     <a:p>
@@ -4448,7 +4508,7 @@
                           </a:solidFill>
                           <a:latin typeface="Helvetica"/>
                         </a:rPr>
-                        <a:t>59%</a:t>
+                        <a:t>59.09%</a:t>
                       </a:r>
                     </a:p>
                     <a:p>
@@ -4479,7 +4539,7 @@
                           </a:solidFill>
                           <a:latin typeface="Helvetica"/>
                         </a:rPr>
-                        <a:t>30%  ⭐</a:t>
+                        <a:t>30.36%  ⭐</a:t>
                       </a:r>
                     </a:p>
                     <a:p>
@@ -4789,73 +4849,73 @@
           <a:p>
             <a:pPr algn="l"/>
             <a:r>
-              <a:rPr sz="2600" b="1" i="0">
+              <a:rPr sz="2400" b="1" i="0">
                 <a:solidFill>
                   <a:srgbClr val="2D8A4E"/>
                 </a:solidFill>
                 <a:latin typeface="Helvetica"/>
               </a:rPr>
-              <a:t>LLaMA-2 70B Base       42%   (best)</a:t>
-            </a:r>
-          </a:p>
-          <a:p>
-            <a:pPr algn="l"/>
-            <a:r>
-              <a:rPr sz="2400" b="0" i="0">
+              <a:t>LLaMA-2 70B Base       42.21%   (best)</a:t>
+            </a:r>
+          </a:p>
+          <a:p>
+            <a:pPr algn="l"/>
+            <a:r>
+              <a:rPr sz="2200" b="0" i="0">
                 <a:solidFill>
                   <a:srgbClr val="000000"/>
                 </a:solidFill>
                 <a:latin typeface="Helvetica"/>
               </a:rPr>
-              <a:t>GPT-3.5 Turbo          34%</a:t>
-            </a:r>
-          </a:p>
-          <a:p>
-            <a:pPr algn="l"/>
-            <a:r>
-              <a:rPr sz="2400" b="0" i="0">
+              <a:t>GPT-3.5 Turbo          34.15%</a:t>
+            </a:r>
+          </a:p>
+          <a:p>
+            <a:pPr algn="l"/>
+            <a:r>
+              <a:rPr sz="2200" b="0" i="0">
                 <a:solidFill>
                   <a:srgbClr val="000000"/>
                 </a:solidFill>
                 <a:latin typeface="Helvetica"/>
               </a:rPr>
-              <a:t>Falcon 40B Base        19%</a:t>
-            </a:r>
-          </a:p>
-          <a:p>
-            <a:pPr algn="l"/>
-            <a:r>
-              <a:rPr sz="2400" b="0" i="0">
+              <a:t>Falcon 40B Base        18.66%</a:t>
+            </a:r>
+          </a:p>
+          <a:p>
+            <a:pPr algn="l"/>
+            <a:r>
+              <a:rPr sz="2200" b="0" i="0">
                 <a:solidFill>
                   <a:srgbClr val="000000"/>
                 </a:solidFill>
                 <a:latin typeface="Helvetica"/>
               </a:rPr>
-              <a:t>Text-Davinci-003       17%</a:t>
-            </a:r>
-          </a:p>
-          <a:p>
-            <a:pPr algn="l"/>
-            <a:r>
-              <a:rPr sz="2400" b="0" i="0">
+              <a:t>Text-Davinci-003       16.76%</a:t>
+            </a:r>
+          </a:p>
+          <a:p>
+            <a:pPr algn="l"/>
+            <a:r>
+              <a:rPr sz="2200" b="0" i="0">
                 <a:solidFill>
                   <a:srgbClr val="000000"/>
                 </a:solidFill>
                 <a:latin typeface="Helvetica"/>
               </a:rPr>
-              <a:t>LLaMA-2 70B Chat       13%</a:t>
-            </a:r>
-          </a:p>
-          <a:p>
-            <a:pPr algn="l"/>
-            <a:r>
-              <a:rPr sz="2600" b="1" i="0">
+              <a:t>LLaMA-2 70B Chat       13.34%</a:t>
+            </a:r>
+          </a:p>
+          <a:p>
+            <a:pPr algn="l"/>
+            <a:r>
+              <a:rPr sz="2400" b="1" i="0">
                 <a:solidFill>
                   <a:srgbClr val="CC4C54"/>
                 </a:solidFill>
                 <a:latin typeface="Helvetica"/>
               </a:rPr>
-              <a:t>Falcon 40B Instruct     1%   (worst)</a:t>
+              <a:t>Falcon 40B Instruct     1.11%   (worst)</a:t>
             </a:r>
           </a:p>
         </p:txBody>
@@ -5198,7 +5258,7 @@
                 </a:solidFill>
                 <a:latin typeface="Helvetica"/>
               </a:rPr>
-              <a:t>Best model only 72% RHT, FCT under 50%</a:t>
+              <a:t>Best model only 72.33% RHT, FCT under 50%</a:t>
             </a:r>
           </a:p>
         </p:txBody>
@@ -5347,7 +5407,7 @@
                 </a:solidFill>
                 <a:latin typeface="Helvetica"/>
               </a:rPr>
-              <a:t>Instruction-Tuning Paradox (Chat: 11%)</a:t>
+              <a:t>Instruction-Tuning Paradox (Chat: 11.26%)</a:t>
             </a:r>
           </a:p>
         </p:txBody>
@@ -5496,7 +5556,7 @@
                 </a:solidFill>
                 <a:latin typeface="Helvetica"/>
               </a:rPr>
-              <a:t>Falcon 30% MHT — limited but useful</a:t>
+              <a:t>Falcon 40B 30.36% MHT — limited but useful</a:t>
             </a:r>
           </a:p>
         </p:txBody>
@@ -6260,7 +6320,7 @@
                 </a:solidFill>
                 <a:latin typeface="Helvetica"/>
               </a:rPr>
-              <a:t>from this paper would worry you the MOST — the 17% FCT score,</a:t>
+              <a:t>from this paper would worry you the MOST — the 16.76% FCT score,</a:t>
             </a:r>
           </a:p>
           <a:p>

</xml_diff>

<commit_message>
vault backup: 2026-05-11 22:11:13
</commit_message>
<xml_diff>
--- a/MyBrain/notes/ucsd/Spring 2026/ECE284/MedHALT_Slides_9_to_15.pptx
+++ b/MyBrain/notes/ucsd/Spring 2026/ECE284/MedHALT_Slides_9_to_15.pptx
@@ -5841,8 +5841,8 @@
         </p:nvSpPr>
         <p:spPr>
           <a:xfrm>
-            <a:off x="548640" y="1280160"/>
-            <a:ext cx="5486400" cy="5029200"/>
+            <a:off x="457200" y="1280160"/>
+            <a:ext cx="5669280" cy="5303520"/>
           </a:xfrm>
           <a:prstGeom prst="rect">
             <a:avLst/>
@@ -5881,19 +5881,43 @@
           <a:p>
             <a:pPr algn="l"/>
             <a:r>
-              <a:rPr sz="2000" b="0" i="0">
+              <a:rPr sz="2200" b="1" i="0">
                 <a:solidFill>
                   <a:srgbClr val="000000"/>
                 </a:solidFill>
                 <a:latin typeface="Helvetica"/>
               </a:rPr>
-              <a:t>1. MCQ ≠ free-form clinical Q&amp;A</a:t>
-            </a:r>
-          </a:p>
-          <a:p>
-            <a:pPr algn="l"/>
-            <a:r>
-              <a:rPr sz="800" b="0" i="0">
+              <a:t>1. Prompt brittleness</a:t>
+            </a:r>
+          </a:p>
+          <a:p>
+            <a:pPr algn="l"/>
+            <a:r>
+              <a:rPr sz="1800" b="0" i="1">
+                <a:solidFill>
+                  <a:srgbClr val="666666"/>
+                </a:solidFill>
+                <a:latin typeface="Helvetica"/>
+              </a:rPr>
+              <a:t>    Same question, different wording</a:t>
+            </a:r>
+          </a:p>
+          <a:p>
+            <a:pPr algn="l"/>
+            <a:r>
+              <a:rPr sz="1800" b="0" i="1">
+                <a:solidFill>
+                  <a:srgbClr val="666666"/>
+                </a:solidFill>
+                <a:latin typeface="Helvetica"/>
+              </a:rPr>
+              <a:t>    → different answer.</a:t>
+            </a:r>
+          </a:p>
+          <a:p>
+            <a:pPr algn="l"/>
+            <a:r>
+              <a:rPr sz="1600" b="0" i="0">
                 <a:solidFill>
                   <a:srgbClr val="000000"/>
                 </a:solidFill>
@@ -5905,19 +5929,43 @@
           <a:p>
             <a:pPr algn="l"/>
             <a:r>
-              <a:rPr sz="2000" b="0" i="0">
+              <a:rPr sz="2200" b="1" i="0">
                 <a:solidFill>
                   <a:srgbClr val="000000"/>
                 </a:solidFill>
                 <a:latin typeface="Helvetica"/>
               </a:rPr>
-              <a:t>2. Only 7 tasks (no planning / multimodal)</a:t>
-            </a:r>
-          </a:p>
-          <a:p>
-            <a:pPr algn="l"/>
-            <a:r>
-              <a:rPr sz="800" b="0" i="0">
+              <a:t>2. Temperature doesn't help</a:t>
+            </a:r>
+          </a:p>
+          <a:p>
+            <a:pPr algn="l"/>
+            <a:r>
+              <a:rPr sz="1800" b="0" i="1">
+                <a:solidFill>
+                  <a:srgbClr val="666666"/>
+                </a:solidFill>
+                <a:latin typeface="Helvetica"/>
+              </a:rPr>
+              <a:t>    Adjusting randomness doesn't fix</a:t>
+            </a:r>
+          </a:p>
+          <a:p>
+            <a:pPr algn="l"/>
+            <a:r>
+              <a:rPr sz="1800" b="0" i="1">
+                <a:solidFill>
+                  <a:srgbClr val="666666"/>
+                </a:solidFill>
+                <a:latin typeface="Helvetica"/>
+              </a:rPr>
+              <a:t>    hallucination. Issue is deeper.</a:t>
+            </a:r>
+          </a:p>
+          <a:p>
+            <a:pPr algn="l"/>
+            <a:r>
+              <a:rPr sz="1600" b="0" i="0">
                 <a:solidFill>
                   <a:srgbClr val="000000"/>
                 </a:solidFill>
@@ -5929,37 +5977,13 @@
           <a:p>
             <a:pPr algn="l"/>
             <a:r>
-              <a:rPr sz="2000" b="0" i="0">
+              <a:rPr sz="2200" b="1" i="0">
                 <a:solidFill>
                   <a:srgbClr val="000000"/>
                 </a:solidFill>
                 <a:latin typeface="Helvetica"/>
               </a:rPr>
-              <a:t>3. Prompt brittleness unsolved</a:t>
-            </a:r>
-          </a:p>
-          <a:p>
-            <a:pPr algn="l"/>
-            <a:r>
-              <a:rPr sz="800" b="0" i="0">
-                <a:solidFill>
-                  <a:srgbClr val="000000"/>
-                </a:solidFill>
-                <a:latin typeface="Helvetica"/>
-              </a:rPr>
-              <a:t/>
-            </a:r>
-          </a:p>
-          <a:p>
-            <a:pPr algn="l"/>
-            <a:r>
-              <a:rPr sz="2000" b="0" i="0">
-                <a:solidFill>
-                  <a:srgbClr val="000000"/>
-                </a:solidFill>
-                <a:latin typeface="Helvetica"/>
-              </a:rPr>
-              <a:t>4. GPT-4 / Claude not tested</a:t>
+              <a:t>3. Examples in prompt don't fix it</a:t>
             </a:r>
           </a:p>
           <a:p>
@@ -5971,7 +5995,31 @@
                 </a:solidFill>
                 <a:latin typeface="Helvetica"/>
               </a:rPr>
-              <a:t>    (publication timing)</a:t>
+              <a:t>    Show the model 5 sample Q&amp;As</a:t>
+            </a:r>
+          </a:p>
+          <a:p>
+            <a:pPr algn="l"/>
+            <a:r>
+              <a:rPr sz="1800" b="0" i="1">
+                <a:solidFill>
+                  <a:srgbClr val="666666"/>
+                </a:solidFill>
+                <a:latin typeface="Helvetica"/>
+              </a:rPr>
+              <a:t>    before asking → only 25% accuracy.</a:t>
+            </a:r>
+          </a:p>
+          <a:p>
+            <a:pPr algn="l"/>
+            <a:r>
+              <a:rPr sz="1800" b="0" i="1">
+                <a:solidFill>
+                  <a:srgbClr val="666666"/>
+                </a:solidFill>
+                <a:latin typeface="Helvetica"/>
+              </a:rPr>
+              <a:t>    Random guess on 4 options = 25%.</a:t>
             </a:r>
           </a:p>
         </p:txBody>
@@ -6019,8 +6067,8 @@
         </p:nvSpPr>
         <p:spPr>
           <a:xfrm>
-            <a:off x="6492240" y="1280160"/>
-            <a:ext cx="5486400" cy="5029200"/>
+            <a:off x="6400800" y="1280160"/>
+            <a:ext cx="5669280" cy="5303520"/>
           </a:xfrm>
           <a:prstGeom prst="rect">
             <a:avLst/>
@@ -6059,31 +6107,43 @@
           <a:p>
             <a:pPr algn="l"/>
             <a:r>
-              <a:rPr sz="2000" b="0" i="0">
+              <a:rPr sz="2200" b="1" i="0">
                 <a:solidFill>
                   <a:srgbClr val="000000"/>
                 </a:solidFill>
                 <a:latin typeface="Helvetica"/>
               </a:rPr>
-              <a:t>5. IT-Paradox: paper shows</a:t>
-            </a:r>
-          </a:p>
-          <a:p>
-            <a:pPr algn="l"/>
-            <a:r>
-              <a:rPr sz="2000" b="0" i="1">
+              <a:t>4. Why does RLHF hurt?</a:t>
+            </a:r>
+          </a:p>
+          <a:p>
+            <a:pPr algn="l"/>
+            <a:r>
+              <a:rPr sz="1800" b="0" i="1">
                 <a:solidFill>
                   <a:srgbClr val="666666"/>
                 </a:solidFill>
                 <a:latin typeface="Helvetica"/>
               </a:rPr>
-              <a:t>   "what" not "why" — needs ablation</a:t>
-            </a:r>
-          </a:p>
-          <a:p>
-            <a:pPr algn="l"/>
-            <a:r>
-              <a:rPr sz="1200" b="0" i="0">
+              <a:t>    Paper shows Chat worse than Base —</a:t>
+            </a:r>
+          </a:p>
+          <a:p>
+            <a:pPr algn="l"/>
+            <a:r>
+              <a:rPr sz="1800" b="0" i="1">
+                <a:solidFill>
+                  <a:srgbClr val="666666"/>
+                </a:solidFill>
+                <a:latin typeface="Helvetica"/>
+              </a:rPr>
+              <a:t>    but never explains the mechanism.</a:t>
+            </a:r>
+          </a:p>
+          <a:p>
+            <a:pPr algn="l"/>
+            <a:r>
+              <a:rPr sz="1600" b="0" i="0">
                 <a:solidFill>
                   <a:srgbClr val="000000"/>
                 </a:solidFill>
@@ -6095,31 +6155,43 @@
           <a:p>
             <a:pPr algn="l"/>
             <a:r>
-              <a:rPr sz="2000" b="0" i="0">
+              <a:rPr sz="2200" b="1" i="0">
                 <a:solidFill>
                   <a:srgbClr val="000000"/>
                 </a:solidFill>
                 <a:latin typeface="Helvetica"/>
               </a:rPr>
-              <a:t>6. Med-PaLM 2 NOT Med-HALT-ed</a:t>
-            </a:r>
-          </a:p>
-          <a:p>
-            <a:pPr algn="l"/>
-            <a:r>
-              <a:rPr sz="2000" b="0" i="1">
+              <a:t>5. Frontier models untested</a:t>
+            </a:r>
+          </a:p>
+          <a:p>
+            <a:pPr algn="l"/>
+            <a:r>
+              <a:rPr sz="1800" b="0" i="1">
                 <a:solidFill>
                   <a:srgbClr val="666666"/>
                 </a:solidFill>
                 <a:latin typeface="Helvetica"/>
               </a:rPr>
-              <a:t>    — clear research gap</a:t>
-            </a:r>
-          </a:p>
-          <a:p>
-            <a:pPr algn="l"/>
-            <a:r>
-              <a:rPr sz="1200" b="0" i="0">
+              <a:t>    Paper tests 2023 models only.</a:t>
+            </a:r>
+          </a:p>
+          <a:p>
+            <a:pPr algn="l"/>
+            <a:r>
+              <a:rPr sz="1800" b="0" i="1">
+                <a:solidFill>
+                  <a:srgbClr val="666666"/>
+                </a:solidFill>
+                <a:latin typeface="Helvetica"/>
+              </a:rPr>
+              <a:t>    GPT-4, Claude, Med-PaLM 2 — unknown.</a:t>
+            </a:r>
+          </a:p>
+          <a:p>
+            <a:pPr algn="l"/>
+            <a:r>
+              <a:rPr sz="1600" b="0" i="0">
                 <a:solidFill>
                   <a:srgbClr val="000000"/>
                 </a:solidFill>
@@ -6131,25 +6203,37 @@
           <a:p>
             <a:pPr algn="l"/>
             <a:r>
-              <a:rPr sz="2000" b="0" i="0">
+              <a:rPr sz="2200" b="1" i="0">
                 <a:solidFill>
                   <a:srgbClr val="000000"/>
                 </a:solidFill>
                 <a:latin typeface="Helvetica"/>
               </a:rPr>
-              <a:t>7. Pointwise Score → RLHF reward</a:t>
-            </a:r>
-          </a:p>
-          <a:p>
-            <a:pPr algn="l"/>
-            <a:r>
-              <a:rPr sz="2000" b="0" i="1">
+              <a:t>6. Use scoring as training signal?</a:t>
+            </a:r>
+          </a:p>
+          <a:p>
+            <a:pPr algn="l"/>
+            <a:r>
+              <a:rPr sz="1800" b="0" i="1">
                 <a:solidFill>
                   <a:srgbClr val="666666"/>
                 </a:solidFill>
                 <a:latin typeface="Helvetica"/>
               </a:rPr>
-              <a:t>    function?  (train honest LLMs)</a:t>
+              <a:t>    What if +1 / −0.25 / 0 becomes a</a:t>
+            </a:r>
+          </a:p>
+          <a:p>
+            <a:pPr algn="l"/>
+            <a:r>
+              <a:rPr sz="1800" b="0" i="1">
+                <a:solidFill>
+                  <a:srgbClr val="666666"/>
+                </a:solidFill>
+                <a:latin typeface="Helvetica"/>
+              </a:rPr>
+              <a:t>    reward to train honest LLMs?</a:t>
             </a:r>
           </a:p>
         </p:txBody>

</xml_diff>

<commit_message>
vault backup: 2026-05-11 22:27:55
</commit_message>
<xml_diff>
--- a/MyBrain/notes/ucsd/Spring 2026/ECE284/MedHALT_Slides_9_to_15.pptx
+++ b/MyBrain/notes/ucsd/Spring 2026/ECE284/MedHALT_Slides_9_to_15.pptx
@@ -6173,7 +6173,7 @@
                 </a:solidFill>
                 <a:latin typeface="Helvetica"/>
               </a:rPr>
-              <a:t>    Paper tests 2023 models only.</a:t>
+              <a:t>    Paper tests Text-Davinci, GPT-3.5,</a:t>
             </a:r>
           </a:p>
           <a:p>
@@ -6185,7 +6185,19 @@
                 </a:solidFill>
                 <a:latin typeface="Helvetica"/>
               </a:rPr>
-              <a:t>    GPT-4, Claude, Med-PaLM 2 — unknown.</a:t>
+              <a:t>    Llama-2, Falcon, MPT.</a:t>
+            </a:r>
+          </a:p>
+          <a:p>
+            <a:pPr algn="l"/>
+            <a:r>
+              <a:rPr sz="1800" b="0" i="1">
+                <a:solidFill>
+                  <a:srgbClr val="666666"/>
+                </a:solidFill>
+                <a:latin typeface="Helvetica"/>
+              </a:rPr>
+              <a:t>    GPT-4 / Claude / Med-PaLM 2 — unknown.</a:t>
             </a:r>
           </a:p>
           <a:p>

</xml_diff>

<commit_message>
vault backup: 2026-05-11 22:47:11
</commit_message>
<xml_diff>
--- a/MyBrain/notes/ucsd/Spring 2026/ECE284/MedHALT_Slides_9_to_15.pptx
+++ b/MyBrain/notes/ucsd/Spring 2026/ECE284/MedHALT_Slides_9_to_15.pptx
@@ -6221,7 +6221,7 @@
                 </a:solidFill>
                 <a:latin typeface="Helvetica"/>
               </a:rPr>
-              <a:t>6. Use scoring as training signal?</a:t>
+              <a:t>6. Use scoring to TRAIN, not just SCORE?</a:t>
             </a:r>
           </a:p>
           <a:p>
@@ -6233,7 +6233,7 @@
                 </a:solidFill>
                 <a:latin typeface="Helvetica"/>
               </a:rPr>
-              <a:t>    What if +1 / −0.25 / 0 becomes a</a:t>
+              <a:t>    Paper uses +1 / −0.25 to grade models.</a:t>
             </a:r>
           </a:p>
           <a:p>
@@ -6245,7 +6245,19 @@
                 </a:solidFill>
                 <a:latin typeface="Helvetica"/>
               </a:rPr>
-              <a:t>    reward to train honest LLMs?</a:t>
+              <a:t>    What if we used the same formula as</a:t>
+            </a:r>
+          </a:p>
+          <a:p>
+            <a:pPr algn="l"/>
+            <a:r>
+              <a:rPr sz="1800" b="0" i="1">
+                <a:solidFill>
+                  <a:srgbClr val="666666"/>
+                </a:solidFill>
+                <a:latin typeface="Helvetica"/>
+              </a:rPr>
+              <a:t>    RLHF reward — train honest LLMs?</a:t>
             </a:r>
           </a:p>
         </p:txBody>

</xml_diff>

<commit_message>
vault backup: 2026-05-11 23:02:37
</commit_message>
<xml_diff>
--- a/MyBrain/notes/ucsd/Spring 2026/ECE284/MedHALT_Slides_9_to_15.pptx
+++ b/MyBrain/notes/ucsd/Spring 2026/ECE284/MedHALT_Slides_9_to_15.pptx
@@ -4809,8 +4809,8 @@
         </p:nvSpPr>
         <p:spPr>
           <a:xfrm>
-            <a:off x="548640" y="2194560"/>
-            <a:ext cx="6858000" cy="3657600"/>
+            <a:off x="457200" y="2103120"/>
+            <a:ext cx="7315200" cy="365760"/>
           </a:xfrm>
           <a:prstGeom prst="rect">
             <a:avLst/>
@@ -4825,111 +4825,581 @@
           <a:p>
             <a:pPr algn="l"/>
             <a:r>
-              <a:rPr sz="2200" b="1" i="0">
+              <a:rPr sz="1800" b="1" i="0">
                 <a:solidFill>
                   <a:srgbClr val="1A3A6B"/>
                 </a:solidFill>
                 <a:latin typeface="Helvetica"/>
               </a:rPr>
-              <a:t>False Confidence Test (FCT) accuracy:</a:t>
-            </a:r>
-          </a:p>
-          <a:p>
-            <a:pPr algn="l"/>
-            <a:r>
-              <a:rPr sz="1200" b="0" i="0">
-                <a:solidFill>
-                  <a:srgbClr val="000000"/>
-                </a:solidFill>
-                <a:latin typeface="Helvetica"/>
-              </a:rPr>
-              <a:t/>
-            </a:r>
-          </a:p>
-          <a:p>
-            <a:pPr algn="l"/>
-            <a:r>
-              <a:rPr sz="2400" b="1" i="0">
-                <a:solidFill>
-                  <a:srgbClr val="2D8A4E"/>
-                </a:solidFill>
-                <a:latin typeface="Helvetica"/>
-              </a:rPr>
-              <a:t>LLaMA-2 70B Base       42.21%   (best)</a:t>
-            </a:r>
-          </a:p>
-          <a:p>
-            <a:pPr algn="l"/>
-            <a:r>
-              <a:rPr sz="2200" b="0" i="0">
-                <a:solidFill>
-                  <a:srgbClr val="000000"/>
-                </a:solidFill>
-                <a:latin typeface="Helvetica"/>
-              </a:rPr>
-              <a:t>GPT-3.5 Turbo          34.15%</a:t>
-            </a:r>
-          </a:p>
-          <a:p>
-            <a:pPr algn="l"/>
-            <a:r>
-              <a:rPr sz="2200" b="0" i="0">
-                <a:solidFill>
-                  <a:srgbClr val="000000"/>
-                </a:solidFill>
-                <a:latin typeface="Helvetica"/>
-              </a:rPr>
-              <a:t>Falcon 40B Base        18.66%</a:t>
-            </a:r>
-          </a:p>
-          <a:p>
-            <a:pPr algn="l"/>
-            <a:r>
-              <a:rPr sz="2200" b="0" i="0">
-                <a:solidFill>
-                  <a:srgbClr val="000000"/>
-                </a:solidFill>
-                <a:latin typeface="Helvetica"/>
-              </a:rPr>
-              <a:t>Text-Davinci-003       16.76%</a:t>
-            </a:r>
-          </a:p>
-          <a:p>
-            <a:pPr algn="l"/>
-            <a:r>
-              <a:rPr sz="2200" b="0" i="0">
-                <a:solidFill>
-                  <a:srgbClr val="000000"/>
-                </a:solidFill>
-                <a:latin typeface="Helvetica"/>
-              </a:rPr>
-              <a:t>LLaMA-2 70B Chat       13.34%</a:t>
-            </a:r>
-          </a:p>
-          <a:p>
-            <a:pPr algn="l"/>
-            <a:r>
-              <a:rPr sz="2400" b="1" i="0">
-                <a:solidFill>
-                  <a:srgbClr val="CC4C54"/>
-                </a:solidFill>
-                <a:latin typeface="Helvetica"/>
-              </a:rPr>
-              <a:t>Falcon 40B Instruct     1.11%   (worst)</a:t>
-            </a:r>
-          </a:p>
-        </p:txBody>
-      </p:sp>
-      <p:sp>
-        <p:nvSpPr>
-          <p:cNvPr id="7" name="TextBox 6"/>
+              <a:t>False Confidence Test (FCT) accuracy — all 12 models in paper Table 2:</a:t>
+            </a:r>
+          </a:p>
+        </p:txBody>
+      </p:sp>
+      <p:graphicFrame>
+        <p:nvGraphicFramePr>
+          <p:cNvPr id="7" name="Table 6"/>
+          <p:cNvGraphicFramePr>
+            <a:graphicFrameLocks noGrp="1"/>
+          </p:cNvGraphicFramePr>
+          <p:nvPr/>
+        </p:nvGraphicFramePr>
+        <p:xfrm>
+          <a:off x="457200" y="2514600"/>
+          <a:ext cx="7315200" cy="4114800"/>
+        </p:xfrm>
+        <a:graphic>
+          <a:graphicData uri="http://schemas.openxmlformats.org/drawingml/2006/table">
+            <a:tbl>
+              <a:tblPr firstRow="1" bandRow="1">
+                <a:tableStyleId>{5C22544A-7EE6-4342-B048-85BDC9FD1C3A}</a:tableStyleId>
+              </a:tblPr>
+              <a:tblGrid>
+                <a:gridCol w="5029200"/>
+                <a:gridCol w="2286000"/>
+              </a:tblGrid>
+              <a:tr h="316523">
+                <a:tc>
+                  <a:txBody>
+                    <a:bodyPr/>
+                    <a:lstStyle/>
+                    <a:p>
+                      <a:pPr algn="l"/>
+                      <a:r>
+                        <a:rPr sz="1600" b="1">
+                          <a:solidFill>
+                            <a:srgbClr val="1A3A6B"/>
+                          </a:solidFill>
+                          <a:latin typeface="Helvetica"/>
+                        </a:rPr>
+                        <a:t>Model</a:t>
+                      </a:r>
+                    </a:p>
+                  </a:txBody>
+                  <a:tcPr>
+                    <a:solidFill>
+                      <a:srgbClr val="F0F4FA"/>
+                    </a:solidFill>
+                  </a:tcPr>
+                </a:tc>
+                <a:tc>
+                  <a:txBody>
+                    <a:bodyPr/>
+                    <a:lstStyle/>
+                    <a:p>
+                      <a:pPr algn="r"/>
+                      <a:r>
+                        <a:rPr sz="1600" b="1">
+                          <a:solidFill>
+                            <a:srgbClr val="1A3A6B"/>
+                          </a:solidFill>
+                          <a:latin typeface="Helvetica"/>
+                        </a:rPr>
+                        <a:t>FCT Acc</a:t>
+                      </a:r>
+                    </a:p>
+                  </a:txBody>
+                  <a:tcPr>
+                    <a:solidFill>
+                      <a:srgbClr val="F0F4FA"/>
+                    </a:solidFill>
+                  </a:tcPr>
+                </a:tc>
+              </a:tr>
+              <a:tr h="316523">
+                <a:tc>
+                  <a:txBody>
+                    <a:bodyPr/>
+                    <a:lstStyle/>
+                    <a:p>
+                      <a:pPr algn="l"/>
+                      <a:r>
+                        <a:rPr sz="1500" b="1">
+                          <a:solidFill>
+                            <a:srgbClr val="2D8A4E"/>
+                          </a:solidFill>
+                          <a:latin typeface="Helvetica"/>
+                        </a:rPr>
+                        <a:t>LLaMA-2 70B (Base)  ⭐ (highest)</a:t>
+                      </a:r>
+                    </a:p>
+                  </a:txBody>
+                  <a:tcPr/>
+                </a:tc>
+                <a:tc>
+                  <a:txBody>
+                    <a:bodyPr/>
+                    <a:lstStyle/>
+                    <a:p>
+                      <a:pPr algn="r"/>
+                      <a:r>
+                        <a:rPr sz="1500" b="1">
+                          <a:solidFill>
+                            <a:srgbClr val="2D8A4E"/>
+                          </a:solidFill>
+                          <a:latin typeface="Helvetica"/>
+                        </a:rPr>
+                        <a:t>42.21%</a:t>
+                      </a:r>
+                    </a:p>
+                  </a:txBody>
+                  <a:tcPr/>
+                </a:tc>
+              </a:tr>
+              <a:tr h="316523">
+                <a:tc>
+                  <a:txBody>
+                    <a:bodyPr/>
+                    <a:lstStyle/>
+                    <a:p>
+                      <a:pPr algn="l"/>
+                      <a:r>
+                        <a:rPr sz="1500" b="0">
+                          <a:solidFill>
+                            <a:srgbClr val="000000"/>
+                          </a:solidFill>
+                          <a:latin typeface="Helvetica"/>
+                        </a:rPr>
+                        <a:t>GPT-3.5 Turbo</a:t>
+                      </a:r>
+                    </a:p>
+                  </a:txBody>
+                  <a:tcPr/>
+                </a:tc>
+                <a:tc>
+                  <a:txBody>
+                    <a:bodyPr/>
+                    <a:lstStyle/>
+                    <a:p>
+                      <a:pPr algn="r"/>
+                      <a:r>
+                        <a:rPr sz="1500" b="0">
+                          <a:solidFill>
+                            <a:srgbClr val="000000"/>
+                          </a:solidFill>
+                          <a:latin typeface="Helvetica"/>
+                        </a:rPr>
+                        <a:t>34.15%</a:t>
+                      </a:r>
+                    </a:p>
+                  </a:txBody>
+                  <a:tcPr/>
+                </a:tc>
+              </a:tr>
+              <a:tr h="316523">
+                <a:tc>
+                  <a:txBody>
+                    <a:bodyPr/>
+                    <a:lstStyle/>
+                    <a:p>
+                      <a:pPr algn="l"/>
+                      <a:r>
+                        <a:rPr sz="1500" b="0">
+                          <a:solidFill>
+                            <a:srgbClr val="000000"/>
+                          </a:solidFill>
+                          <a:latin typeface="Helvetica"/>
+                        </a:rPr>
+                        <a:t>Falcon 40B (Base)</a:t>
+                      </a:r>
+                    </a:p>
+                  </a:txBody>
+                  <a:tcPr/>
+                </a:tc>
+                <a:tc>
+                  <a:txBody>
+                    <a:bodyPr/>
+                    <a:lstStyle/>
+                    <a:p>
+                      <a:pPr algn="r"/>
+                      <a:r>
+                        <a:rPr sz="1500" b="0">
+                          <a:solidFill>
+                            <a:srgbClr val="000000"/>
+                          </a:solidFill>
+                          <a:latin typeface="Helvetica"/>
+                        </a:rPr>
+                        <a:t>18.66%</a:t>
+                      </a:r>
+                    </a:p>
+                  </a:txBody>
+                  <a:tcPr/>
+                </a:tc>
+              </a:tr>
+              <a:tr h="316523">
+                <a:tc>
+                  <a:txBody>
+                    <a:bodyPr/>
+                    <a:lstStyle/>
+                    <a:p>
+                      <a:pPr algn="l"/>
+                      <a:r>
+                        <a:rPr sz="1500" b="0">
+                          <a:solidFill>
+                            <a:srgbClr val="000000"/>
+                          </a:solidFill>
+                          <a:latin typeface="Helvetica"/>
+                        </a:rPr>
+                        <a:t>Text-Davinci-003</a:t>
+                      </a:r>
+                    </a:p>
+                  </a:txBody>
+                  <a:tcPr/>
+                </a:tc>
+                <a:tc>
+                  <a:txBody>
+                    <a:bodyPr/>
+                    <a:lstStyle/>
+                    <a:p>
+                      <a:pPr algn="r"/>
+                      <a:r>
+                        <a:rPr sz="1500" b="0">
+                          <a:solidFill>
+                            <a:srgbClr val="000000"/>
+                          </a:solidFill>
+                          <a:latin typeface="Helvetica"/>
+                        </a:rPr>
+                        <a:t>16.76%</a:t>
+                      </a:r>
+                    </a:p>
+                  </a:txBody>
+                  <a:tcPr/>
+                </a:tc>
+              </a:tr>
+              <a:tr h="316523">
+                <a:tc>
+                  <a:txBody>
+                    <a:bodyPr/>
+                    <a:lstStyle/>
+                    <a:p>
+                      <a:pPr algn="l"/>
+                      <a:r>
+                        <a:rPr sz="1500" b="0">
+                          <a:solidFill>
+                            <a:srgbClr val="000000"/>
+                          </a:solidFill>
+                          <a:latin typeface="Helvetica"/>
+                        </a:rPr>
+                        <a:t>LLaMA-2 70B Chat</a:t>
+                      </a:r>
+                    </a:p>
+                  </a:txBody>
+                  <a:tcPr/>
+                </a:tc>
+                <a:tc>
+                  <a:txBody>
+                    <a:bodyPr/>
+                    <a:lstStyle/>
+                    <a:p>
+                      <a:pPr algn="r"/>
+                      <a:r>
+                        <a:rPr sz="1500" b="0">
+                          <a:solidFill>
+                            <a:srgbClr val="000000"/>
+                          </a:solidFill>
+                          <a:latin typeface="Helvetica"/>
+                        </a:rPr>
+                        <a:t>13.34%</a:t>
+                      </a:r>
+                    </a:p>
+                  </a:txBody>
+                  <a:tcPr/>
+                </a:tc>
+              </a:tr>
+              <a:tr h="316523">
+                <a:tc>
+                  <a:txBody>
+                    <a:bodyPr/>
+                    <a:lstStyle/>
+                    <a:p>
+                      <a:pPr algn="l"/>
+                      <a:r>
+                        <a:rPr sz="1500" b="0">
+                          <a:solidFill>
+                            <a:srgbClr val="000000"/>
+                          </a:solidFill>
+                          <a:latin typeface="Helvetica"/>
+                        </a:rPr>
+                        <a:t>LLaMA-2 13B-chat</a:t>
+                      </a:r>
+                    </a:p>
+                  </a:txBody>
+                  <a:tcPr/>
+                </a:tc>
+                <a:tc>
+                  <a:txBody>
+                    <a:bodyPr/>
+                    <a:lstStyle/>
+                    <a:p>
+                      <a:pPr algn="r"/>
+                      <a:r>
+                        <a:rPr sz="1500" b="0">
+                          <a:solidFill>
+                            <a:srgbClr val="000000"/>
+                          </a:solidFill>
+                          <a:latin typeface="Helvetica"/>
+                        </a:rPr>
+                        <a:t>7.95%</a:t>
+                      </a:r>
+                    </a:p>
+                  </a:txBody>
+                  <a:tcPr/>
+                </a:tc>
+              </a:tr>
+              <a:tr h="316523">
+                <a:tc>
+                  <a:txBody>
+                    <a:bodyPr/>
+                    <a:lstStyle/>
+                    <a:p>
+                      <a:pPr algn="l"/>
+                      <a:r>
+                        <a:rPr sz="1500" b="0">
+                          <a:solidFill>
+                            <a:srgbClr val="000000"/>
+                          </a:solidFill>
+                          <a:latin typeface="Helvetica"/>
+                        </a:rPr>
+                        <a:t>LLaMA-2 13B (Base)</a:t>
+                      </a:r>
+                    </a:p>
+                  </a:txBody>
+                  <a:tcPr/>
+                </a:tc>
+                <a:tc>
+                  <a:txBody>
+                    <a:bodyPr/>
+                    <a:lstStyle/>
+                    <a:p>
+                      <a:pPr algn="r"/>
+                      <a:r>
+                        <a:rPr sz="1500" b="0">
+                          <a:solidFill>
+                            <a:srgbClr val="000000"/>
+                          </a:solidFill>
+                          <a:latin typeface="Helvetica"/>
+                        </a:rPr>
+                        <a:t>1.72%</a:t>
+                      </a:r>
+                    </a:p>
+                  </a:txBody>
+                  <a:tcPr/>
+                </a:tc>
+              </a:tr>
+              <a:tr h="316523">
+                <a:tc>
+                  <a:txBody>
+                    <a:bodyPr/>
+                    <a:lstStyle/>
+                    <a:p>
+                      <a:pPr algn="l"/>
+                      <a:r>
+                        <a:rPr sz="1500" b="0">
+                          <a:solidFill>
+                            <a:srgbClr val="000000"/>
+                          </a:solidFill>
+                          <a:latin typeface="Helvetica"/>
+                        </a:rPr>
+                        <a:t>Falcon 40B Instruct</a:t>
+                      </a:r>
+                    </a:p>
+                  </a:txBody>
+                  <a:tcPr/>
+                </a:tc>
+                <a:tc>
+                  <a:txBody>
+                    <a:bodyPr/>
+                    <a:lstStyle/>
+                    <a:p>
+                      <a:pPr algn="r"/>
+                      <a:r>
+                        <a:rPr sz="1500" b="0">
+                          <a:solidFill>
+                            <a:srgbClr val="000000"/>
+                          </a:solidFill>
+                          <a:latin typeface="Helvetica"/>
+                        </a:rPr>
+                        <a:t>1.11%</a:t>
+                      </a:r>
+                    </a:p>
+                  </a:txBody>
+                  <a:tcPr/>
+                </a:tc>
+              </a:tr>
+              <a:tr h="316523">
+                <a:tc>
+                  <a:txBody>
+                    <a:bodyPr/>
+                    <a:lstStyle/>
+                    <a:p>
+                      <a:pPr algn="l"/>
+                      <a:r>
+                        <a:rPr sz="1500" b="0">
+                          <a:solidFill>
+                            <a:srgbClr val="000000"/>
+                          </a:solidFill>
+                          <a:latin typeface="Helvetica"/>
+                        </a:rPr>
+                        <a:t>MPT 7B (Base)</a:t>
+                      </a:r>
+                    </a:p>
+                  </a:txBody>
+                  <a:tcPr/>
+                </a:tc>
+                <a:tc>
+                  <a:txBody>
+                    <a:bodyPr/>
+                    <a:lstStyle/>
+                    <a:p>
+                      <a:pPr algn="r"/>
+                      <a:r>
+                        <a:rPr sz="1500" b="0">
+                          <a:solidFill>
+                            <a:srgbClr val="000000"/>
+                          </a:solidFill>
+                          <a:latin typeface="Helvetica"/>
+                        </a:rPr>
+                        <a:t>0.85%</a:t>
+                      </a:r>
+                    </a:p>
+                  </a:txBody>
+                  <a:tcPr/>
+                </a:tc>
+              </a:tr>
+              <a:tr h="316523">
+                <a:tc>
+                  <a:txBody>
+                    <a:bodyPr/>
+                    <a:lstStyle/>
+                    <a:p>
+                      <a:pPr algn="l"/>
+                      <a:r>
+                        <a:rPr sz="1500" b="0">
+                          <a:solidFill>
+                            <a:srgbClr val="000000"/>
+                          </a:solidFill>
+                          <a:latin typeface="Helvetica"/>
+                        </a:rPr>
+                        <a:t>LLaMA-2 7B (Base)</a:t>
+                      </a:r>
+                    </a:p>
+                  </a:txBody>
+                  <a:tcPr/>
+                </a:tc>
+                <a:tc>
+                  <a:txBody>
+                    <a:bodyPr/>
+                    <a:lstStyle/>
+                    <a:p>
+                      <a:pPr algn="r"/>
+                      <a:r>
+                        <a:rPr sz="1500" b="0">
+                          <a:solidFill>
+                            <a:srgbClr val="000000"/>
+                          </a:solidFill>
+                          <a:latin typeface="Helvetica"/>
+                        </a:rPr>
+                        <a:t>0.45%</a:t>
+                      </a:r>
+                    </a:p>
+                  </a:txBody>
+                  <a:tcPr/>
+                </a:tc>
+              </a:tr>
+              <a:tr h="316523">
+                <a:tc>
+                  <a:txBody>
+                    <a:bodyPr/>
+                    <a:lstStyle/>
+                    <a:p>
+                      <a:pPr algn="l"/>
+                      <a:r>
+                        <a:rPr sz="1500" b="0">
+                          <a:solidFill>
+                            <a:srgbClr val="000000"/>
+                          </a:solidFill>
+                          <a:latin typeface="Helvetica"/>
+                        </a:rPr>
+                        <a:t>LLaMA-2 7B-chat</a:t>
+                      </a:r>
+                    </a:p>
+                  </a:txBody>
+                  <a:tcPr/>
+                </a:tc>
+                <a:tc>
+                  <a:txBody>
+                    <a:bodyPr/>
+                    <a:lstStyle/>
+                    <a:p>
+                      <a:pPr algn="r"/>
+                      <a:r>
+                        <a:rPr sz="1500" b="0">
+                          <a:solidFill>
+                            <a:srgbClr val="000000"/>
+                          </a:solidFill>
+                          <a:latin typeface="Helvetica"/>
+                        </a:rPr>
+                        <a:t>0.42%</a:t>
+                      </a:r>
+                    </a:p>
+                  </a:txBody>
+                  <a:tcPr/>
+                </a:tc>
+              </a:tr>
+              <a:tr h="316524">
+                <a:tc>
+                  <a:txBody>
+                    <a:bodyPr/>
+                    <a:lstStyle/>
+                    <a:p>
+                      <a:pPr algn="l"/>
+                      <a:r>
+                        <a:rPr sz="1500" b="1">
+                          <a:solidFill>
+                            <a:srgbClr val="CC4C54"/>
+                          </a:solidFill>
+                          <a:latin typeface="Helvetica"/>
+                        </a:rPr>
+                        <a:t>MPT 7B Instruct  ❌ (lowest)</a:t>
+                      </a:r>
+                    </a:p>
+                  </a:txBody>
+                  <a:tcPr/>
+                </a:tc>
+                <a:tc>
+                  <a:txBody>
+                    <a:bodyPr/>
+                    <a:lstStyle/>
+                    <a:p>
+                      <a:pPr algn="r"/>
+                      <a:r>
+                        <a:rPr sz="1500" b="1">
+                          <a:solidFill>
+                            <a:srgbClr val="CC4C54"/>
+                          </a:solidFill>
+                          <a:latin typeface="Helvetica"/>
+                        </a:rPr>
+                        <a:t>0.17%</a:t>
+                      </a:r>
+                    </a:p>
+                  </a:txBody>
+                  <a:tcPr/>
+                </a:tc>
+              </a:tr>
+            </a:tbl>
+          </a:graphicData>
+        </a:graphic>
+      </p:graphicFrame>
+      <p:sp>
+        <p:nvSpPr>
+          <p:cNvPr id="8" name="TextBox 7"/>
           <p:cNvSpPr txBox="1"/>
           <p:nvPr/>
         </p:nvSpPr>
         <p:spPr>
           <a:xfrm>
-            <a:off x="7589520" y="2560320"/>
-            <a:ext cx="4389120" cy="2286000"/>
+            <a:off x="8046720" y="2651760"/>
+            <a:ext cx="4023360" cy="3657600"/>
           </a:xfrm>
           <a:prstGeom prst="rect">
             <a:avLst/>
@@ -4944,25 +5414,25 @@
           <a:p>
             <a:pPr algn="l"/>
             <a:r>
-              <a:rPr sz="2400" b="1" i="0">
+              <a:rPr sz="2200" b="1" i="0">
                 <a:solidFill>
                   <a:srgbClr val="1A3A6B"/>
                 </a:solidFill>
                 <a:latin typeface="Helvetica"/>
               </a:rPr>
-              <a:t>💡 LLM amplifies the user's</a:t>
-            </a:r>
-          </a:p>
-          <a:p>
-            <a:pPr algn="l"/>
-            <a:r>
-              <a:rPr sz="2400" b="1" i="0">
+              <a:t>💡 LLM amplifies the</a:t>
+            </a:r>
+          </a:p>
+          <a:p>
+            <a:pPr algn="l"/>
+            <a:r>
+              <a:rPr sz="2200" b="1" i="0">
                 <a:solidFill>
                   <a:srgbClr val="1A3A6B"/>
                 </a:solidFill>
                 <a:latin typeface="Helvetica"/>
               </a:rPr>
-              <a:t>    wrong assumption</a:t>
+              <a:t>    user's wrong assumption</a:t>
             </a:r>
           </a:p>
           <a:p>
@@ -4980,7 +5450,7 @@
           <a:p>
             <a:pPr algn="l"/>
             <a:r>
-              <a:rPr sz="1800" b="1" i="1">
+              <a:rPr sz="1600" b="1" i="1">
                 <a:solidFill>
                   <a:srgbClr val="D9A73C"/>
                 </a:solidFill>
@@ -4989,39 +5459,40 @@
               <a:t>(confirmation bias amplifier)</a:t>
             </a:r>
           </a:p>
-        </p:txBody>
-      </p:sp>
-      <p:sp>
-        <p:nvSpPr>
-          <p:cNvPr id="8" name="TextBox 7"/>
-          <p:cNvSpPr txBox="1"/>
-          <p:nvPr/>
-        </p:nvSpPr>
-        <p:spPr>
-          <a:xfrm>
-            <a:off x="548640" y="6126480"/>
-            <a:ext cx="11155680" cy="457200"/>
-          </a:xfrm>
-          <a:prstGeom prst="rect">
-            <a:avLst/>
-          </a:prstGeom>
-          <a:noFill/>
-        </p:spPr>
-        <p:txBody>
-          <a:bodyPr wrap="square" lIns="45720" rIns="45720" tIns="18288" bIns="18288">
-            <a:spAutoFit/>
-          </a:bodyPr>
-          <a:lstStyle/>
-          <a:p>
-            <a:pPr algn="l"/>
-            <a:r>
-              <a:rPr sz="1600" b="0" i="1">
+          <a:p>
+            <a:pPr algn="l"/>
+            <a:r>
+              <a:rPr sz="1200" b="0" i="0">
+                <a:solidFill>
+                  <a:srgbClr val="000000"/>
+                </a:solidFill>
+                <a:latin typeface="Helvetica"/>
+              </a:rPr>
+              <a:t/>
+            </a:r>
+          </a:p>
+          <a:p>
+            <a:pPr algn="l"/>
+            <a:r>
+              <a:rPr sz="1400" b="0" i="1">
                 <a:solidFill>
                   <a:srgbClr val="666666"/>
                 </a:solidFill>
                 <a:latin typeface="Helvetica"/>
               </a:rPr>
-              <a:t>— Recall Yixian's Lyme example earlier — that was FCT in action.</a:t>
+              <a:t>Recall Yixian's Lyme example —</a:t>
+            </a:r>
+          </a:p>
+          <a:p>
+            <a:pPr algn="l"/>
+            <a:r>
+              <a:rPr sz="1400" b="0" i="1">
+                <a:solidFill>
+                  <a:srgbClr val="666666"/>
+                </a:solidFill>
+                <a:latin typeface="Helvetica"/>
+              </a:rPr>
+              <a:t>that was FCT in action.</a:t>
             </a:r>
           </a:p>
         </p:txBody>

</xml_diff>

<commit_message>
vault backup: 2026-05-11 23:20:06
</commit_message>
<xml_diff>
--- a/MyBrain/notes/ucsd/Spring 2026/ECE284/MedHALT_Slides_9_to_15.pptx
+++ b/MyBrain/notes/ucsd/Spring 2026/ECE284/MedHALT_Slides_9_to_15.pptx
@@ -6460,37 +6460,73 @@
           <a:p>
             <a:pPr algn="l"/>
             <a:r>
-              <a:rPr sz="1800" b="0" i="1">
+              <a:rPr sz="1600" b="0" i="1">
                 <a:solidFill>
                   <a:srgbClr val="666666"/>
                 </a:solidFill>
                 <a:latin typeface="Helvetica"/>
               </a:rPr>
-              <a:t>    Show the model 5 sample Q&amp;As</a:t>
-            </a:r>
-          </a:p>
-          <a:p>
-            <a:pPr algn="l"/>
-            <a:r>
-              <a:rPr sz="1800" b="0" i="1">
+              <a:t>    % of Med-HALT questions GPT-3.5</a:t>
+            </a:r>
+          </a:p>
+          <a:p>
+            <a:pPr algn="l"/>
+            <a:r>
+              <a:rPr sz="1600" b="0" i="1">
                 <a:solidFill>
                   <a:srgbClr val="666666"/>
                 </a:solidFill>
                 <a:latin typeface="Helvetica"/>
               </a:rPr>
-              <a:t>    before asking → only 25% accuracy.</a:t>
-            </a:r>
-          </a:p>
-          <a:p>
-            <a:pPr algn="l"/>
-            <a:r>
-              <a:rPr sz="1800" b="0" i="1">
+              <a:t>    answers correctly:</a:t>
+            </a:r>
+          </a:p>
+          <a:p>
+            <a:pPr algn="l"/>
+            <a:r>
+              <a:rPr sz="1700" b="0" i="1">
                 <a:solidFill>
                   <a:srgbClr val="666666"/>
                 </a:solidFill>
                 <a:latin typeface="Helvetica"/>
               </a:rPr>
-              <a:t>    Random guess on 4 options = 25%.</a:t>
+              <a:t>      • 0 examples in prompt → 7.31%</a:t>
+            </a:r>
+          </a:p>
+          <a:p>
+            <a:pPr algn="l"/>
+            <a:r>
+              <a:rPr sz="1700" b="0" i="1">
+                <a:solidFill>
+                  <a:srgbClr val="666666"/>
+                </a:solidFill>
+                <a:latin typeface="Helvetica"/>
+              </a:rPr>
+              <a:t>      • 5 examples in prompt → ~25%</a:t>
+            </a:r>
+          </a:p>
+          <a:p>
+            <a:pPr algn="l"/>
+            <a:r>
+              <a:rPr sz="1700" b="0" i="1">
+                <a:solidFill>
+                  <a:srgbClr val="666666"/>
+                </a:solidFill>
+                <a:latin typeface="Helvetica"/>
+              </a:rPr>
+              <a:t>      • Random guess (4 choices) = 25%</a:t>
+            </a:r>
+          </a:p>
+          <a:p>
+            <a:pPr algn="l"/>
+            <a:r>
+              <a:rPr sz="1600" b="0" i="1">
+                <a:solidFill>
+                  <a:srgbClr val="666666"/>
+                </a:solidFill>
+                <a:latin typeface="Helvetica"/>
+              </a:rPr>
+              <a:t>    → Examples teach format, not knowledge.</a:t>
             </a:r>
           </a:p>
         </p:txBody>

</xml_diff>